<commit_message>
OE1 completo: 8 sensores funcionando con dashboard en tiempo real
</commit_message>
<xml_diff>
--- a/docs/evidencias_grupales_fase1/DomoVidaPresentacion.pptx
+++ b/docs/evidencias_grupales_fase1/DomoVidaPresentacion.pptx
@@ -140,14 +140,6 @@
     </p:ext>
   </p:extLst>
 </p:presentation>
-</file>
-
-<file path=ppt/revisionInfo.xml><?xml version="1.0" encoding="utf-8"?>
-<p1510:revInfo xmlns:a="http://schemas.openxmlformats.org/drawingml/2006/main" xmlns:r="http://schemas.openxmlformats.org/officeDocument/2006/relationships" xmlns:p1510="http://schemas.microsoft.com/office/powerpoint/2015/10/main">
-  <p1510:revLst>
-    <p1510:client id="{03894FC9-DC6E-4E01-A42A-AD24DD1D599C}" v="2" dt="2026-09-16T17:42:37.989"/>
-  </p1510:revLst>
-</p1510:revInfo>
 </file>
 
 <file path=ppt/changesInfos/changesInfo1.xml><?xml version="1.0" encoding="utf-8"?>
@@ -6398,7 +6390,7 @@
               <a:t>Diseñar, </a:t>
             </a:r>
             <a:r>
-              <a:rPr lang="en-US" sz="900">
+              <a:rPr lang="en-US" sz="900" dirty="0" err="1">
                 <a:solidFill>
                   <a:srgbClr val="2C3249"/>
                 </a:solidFill>
@@ -6406,7 +6398,7 @@
                 <a:ea typeface="Martel Sans" pitchFamily="34" charset="-122"/>
                 <a:cs typeface="Martel Sans" pitchFamily="34" charset="-120"/>
               </a:rPr>
-              <a:t>construir </a:t>
+              <a:t>construir</a:t>
             </a:r>
             <a:r>
               <a:rPr lang="en-US" sz="900" dirty="0">
@@ -6417,7 +6409,7 @@
                 <a:ea typeface="Martel Sans" pitchFamily="34" charset="-122"/>
                 <a:cs typeface="Martel Sans" pitchFamily="34" charset="-120"/>
               </a:rPr>
-              <a:t>e implementar una plataforma IoT de monitoreo predictivo para el adulto mayor en el hogar.</a:t>
+              <a:t> e implementar una plataforma IoT de monitoreo predictivo para el adulto mayor en el hogar.</a:t>
             </a:r>
             <a:endParaRPr lang="en-US" sz="900" dirty="0"/>
           </a:p>

</xml_diff>